<commit_message>
Update presentation for Research Lens AI Sprint 2
</commit_message>
<xml_diff>
--- a/presentations/ResearchLens_AI_Sprint2_Update.pptx
+++ b/presentations/ResearchLens_AI_Sprint2_Update.pptx
@@ -595,7 +595,7 @@
           <a:p>
             <a:r>
               <a:rPr lang="en-US" dirty="0"/>
-              <a:t>Four core objectives for Sprint 2: multi-source search, project CRUD, account settings, and the visual redesign.</a:t>
+              <a:t>Four core objectives for Sprint 2: multi-source search, project CRUD, account settings (including self-service account deletion), and the visual redesign.</a:t>
             </a:r>
             <a:endParaRPr lang="en-US" dirty="0"/>
           </a:p>
@@ -859,7 +859,7 @@
           <a:p>
             <a:r>
               <a:rPr lang="en-US" dirty="0"/>
-              <a:t>Key achievements: two sources merged, full CRUD, the DetachedInstanceError fix, the redesign, settings, and search filters/pagination.</a:t>
+              <a:t>Key achievements: two sources merged, full CRUD, the DetachedInstanceError fix, the redesign, settings with password changes and account deletion, and search filters/pagination.</a:t>
             </a:r>
             <a:endParaRPr lang="en-US" dirty="0"/>
           </a:p>
@@ -2468,7 +2468,7 @@
                 <a:ea typeface="Calibri" pitchFamily="34" charset="-122"/>
                 <a:cs typeface="Calibri" pitchFamily="34" charset="-120"/>
               </a:rPr>
-              <a:t>A dedicated Settings page for updating name, email display, and changing password securely.</a:t>
+              <a:t>A dedicated Settings page for name and password changes, plus self-service account deletion.</a:t>
             </a:r>
             <a:endParaRPr lang="en-US" sz="1200" dirty="0"/>
           </a:p>
@@ -3255,7 +3255,7 @@
                 <a:ea typeface="Calibri" pitchFamily="34" charset="-122"/>
                 <a:cs typeface="Calibri" pitchFamily="34" charset="-120"/>
               </a:rPr>
-              <a:t>Fixed a critical session bug affecting every project view</a:t>
+              <a:t>Self-service account deletion, with full data cleanup</a:t>
             </a:r>
             <a:endParaRPr lang="en-US" sz="1300" dirty="0"/>
           </a:p>
@@ -3263,7 +3263,7 @@
       </p:sp>
       <p:pic>
         <p:nvPicPr>
-          <p:cNvPr id="18" name="Image 7" descr="/tmp/pptx_work/assets/frame_dashboard.png">    </p:cNvPr>
+          <p:cNvPr id="18" name="Image 7" descr="/tmp/pptx_work/assets/check_green.png">    </p:cNvPr>
           <p:cNvPicPr>
             <a:picLocks noChangeAspect="1"/>
           </p:cNvPicPr>
@@ -3277,6 +3277,69 @@
         </p:blipFill>
         <p:spPr>
           <a:xfrm>
+            <a:off x="548640" y="5751576"/>
+            <a:ext cx="219456" cy="219456"/>
+          </a:xfrm>
+          <a:prstGeom prst="rect">
+            <a:avLst/>
+          </a:prstGeom>
+        </p:spPr>
+      </p:pic>
+      <p:sp>
+        <p:nvSpPr>
+          <p:cNvPr id="19" name="Text 9"/>
+          <p:cNvSpPr txBox="1"/>
+          <p:nvPr/>
+        </p:nvSpPr>
+        <p:spPr>
+          <a:xfrm>
+            <a:off x="896112" y="5669280"/>
+            <a:ext cx="4297680" cy="457200"/>
+          </a:xfrm>
+          <a:prstGeom prst="rect">
+            <a:avLst/>
+          </a:prstGeom>
+          <a:noFill/>
+          <a:ln/>
+        </p:spPr>
+        <p:txBody>
+          <a:bodyPr wrap="square" lIns="0" tIns="0" rIns="0" bIns="0" rtlCol="0" anchor="t"/>
+          <a:lstStyle/>
+          <a:p>
+            <a:pPr indent="0" marL="0">
+              <a:buNone/>
+            </a:pPr>
+            <a:r>
+              <a:rPr lang="en-US" sz="1300" dirty="0">
+                <a:solidFill>
+                  <a:srgbClr val="0F172A"/>
+                </a:solidFill>
+                <a:latin typeface="Calibri" pitchFamily="34" charset="0"/>
+                <a:ea typeface="Calibri" pitchFamily="34" charset="-122"/>
+                <a:cs typeface="Calibri" pitchFamily="34" charset="-120"/>
+              </a:rPr>
+              <a:t>Fixed a critical session bug affecting every project view</a:t>
+            </a:r>
+            <a:endParaRPr lang="en-US" sz="1300" dirty="0"/>
+          </a:p>
+        </p:txBody>
+      </p:sp>
+      <p:pic>
+        <p:nvPicPr>
+          <p:cNvPr id="20" name="Image 8" descr="/tmp/pptx_work/assets/frame_dashboard.png">    </p:cNvPr>
+          <p:cNvPicPr>
+            <a:picLocks noChangeAspect="1"/>
+          </p:cNvPicPr>
+          <p:nvPr/>
+        </p:nvPicPr>
+        <p:blipFill>
+          <a:blip r:embed="rId9"/>
+          <a:stretch>
+            <a:fillRect/>
+          </a:stretch>
+        </p:blipFill>
+        <p:spPr>
+          <a:xfrm>
             <a:off x="5349240" y="1554480"/>
             <a:ext cx="6492240" cy="4391035"/>
           </a:xfrm>
@@ -3287,7 +3350,7 @@
       </p:pic>
       <p:sp>
         <p:nvSpPr>
-          <p:cNvPr id="19" name="Text 9"/>
+          <p:cNvPr id="21" name="Text 10"/>
           <p:cNvSpPr txBox="1"/>
           <p:nvPr/>
         </p:nvSpPr>
@@ -3326,7 +3389,7 @@
       </p:sp>
       <p:sp>
         <p:nvSpPr>
-          <p:cNvPr id="20" name="Text 10"/>
+          <p:cNvPr id="22" name="Text 11"/>
           <p:cNvSpPr txBox="1"/>
           <p:nvPr/>
         </p:nvSpPr>
@@ -3365,7 +3428,7 @@
       </p:sp>
       <p:sp>
         <p:nvSpPr>
-          <p:cNvPr id="21" name="Text 11"/>
+          <p:cNvPr id="23" name="Text 12"/>
           <p:cNvSpPr txBox="1"/>
           <p:nvPr/>
         </p:nvSpPr>
@@ -5855,7 +5918,7 @@
                 <a:ea typeface="Calibri" pitchFamily="34" charset="-122"/>
                 <a:cs typeface="Calibri" pitchFamily="34" charset="-120"/>
               </a:rPr>
-              <a:t>Built a Settings page with a secure password-change flow</a:t>
+              <a:t>Built Settings with password changes and secure account deletion</a:t>
             </a:r>
             <a:endParaRPr lang="en-US" sz="1200" dirty="0"/>
           </a:p>
@@ -6476,7 +6539,7 @@
                 <a:ea typeface="Calibri" pitchFamily="34" charset="-122"/>
                 <a:cs typeface="Calibri" pitchFamily="34" charset="-120"/>
               </a:rPr>
-              <a:t>Settings — name &amp; password management</a:t>
+              <a:t>Settings — profile, password &amp; account deletion</a:t>
             </a:r>
             <a:endParaRPr lang="en-US" sz="1250" dirty="0"/>
           </a:p>

</xml_diff>